<commit_message>
Update: Dynamic balance, transaction history, and detailed receipts implemented
</commit_message>
<xml_diff>
--- a/Tatum_Bank_Presentation.pptx
+++ b/Tatum_Bank_Presentation.pptx
@@ -4,22 +4,25 @@
   <p:sldMasterIdLst>
     <p:sldMasterId id="2147483648" r:id="rId1"/>
   </p:sldMasterIdLst>
+  <p:notesMasterIdLst>
+    <p:notesMasterId r:id="rId15"/>
+  </p:notesMasterIdLst>
   <p:sldIdLst>
-    <p:sldId id="256" r:id="rId7"/>
-    <p:sldId id="257" r:id="rId8"/>
-    <p:sldId id="258" r:id="rId9"/>
-    <p:sldId id="259" r:id="rId11"/>
-    <p:sldId id="260" r:id="rId12"/>
-    <p:sldId id="261" r:id="rId13"/>
-    <p:sldId id="262" r:id="rId14"/>
-    <p:sldId id="263" r:id="rId15"/>
-    <p:sldId id="264" r:id="rId16"/>
-    <p:sldId id="265" r:id="rId17"/>
-    <p:sldId id="266" r:id="rId18"/>
-    <p:sldId id="267" r:id="rId19"/>
-    <p:sldId id="268" r:id="rId20"/>
+    <p:sldId id="256" r:id="rId2"/>
+    <p:sldId id="257" r:id="rId3"/>
+    <p:sldId id="258" r:id="rId4"/>
+    <p:sldId id="259" r:id="rId5"/>
+    <p:sldId id="260" r:id="rId6"/>
+    <p:sldId id="261" r:id="rId7"/>
+    <p:sldId id="262" r:id="rId8"/>
+    <p:sldId id="263" r:id="rId9"/>
+    <p:sldId id="264" r:id="rId10"/>
+    <p:sldId id="265" r:id="rId11"/>
+    <p:sldId id="266" r:id="rId12"/>
+    <p:sldId id="267" r:id="rId13"/>
+    <p:sldId id="268" r:id="rId14"/>
   </p:sldIdLst>
-  <p:sldSz cx="12191695" cy="6858000" type="screen4x3"/>
+  <p:sldSz cx="12192000" cy="6858000"/>
   <p:notesSz cx="6858000" cy="9144000"/>
   <p:defaultTextStyle>
     <a:defPPr>
@@ -116,11 +119,27 @@
       </a:defRPr>
     </a:lvl9pPr>
   </p:defaultTextStyle>
+  <p:extLst>
+    <p:ext uri="{EFAFB233-063F-42B5-8137-9DF3F51BA10A}">
+      <p15:sldGuideLst xmlns:p15="http://schemas.microsoft.com/office/powerpoint/2012/main">
+        <p15:guide id="1" orient="horz" pos="2160">
+          <p15:clr>
+            <a:srgbClr val="A4A3A4"/>
+          </p15:clr>
+        </p15:guide>
+        <p15:guide id="2" pos="2880">
+          <p15:clr>
+            <a:srgbClr val="A4A3A4"/>
+          </p15:clr>
+        </p15:guide>
+      </p15:sldGuideLst>
+    </p:ext>
+  </p:extLst>
 </p:presentation>
 </file>
 
 <file path=ppt/notesMasters/notesMaster1.xml><?xml version="1.0" encoding="utf-8"?>
-<p:notesMaster xmlns:a="http://schemas.openxmlformats.org/drawingml/2006/main" xmlns:p="http://schemas.openxmlformats.org/presentationml/2006/main" xmlns:r="http://schemas.openxmlformats.org/officeDocument/2006/relationships">
+<p:notesMaster xmlns:a="http://schemas.openxmlformats.org/drawingml/2006/main" xmlns:r="http://schemas.openxmlformats.org/officeDocument/2006/relationships" xmlns:p="http://schemas.openxmlformats.org/presentationml/2006/main">
   <p:cSld>
     <p:bg>
       <p:bgRef idx="1001">
@@ -154,7 +173,7 @@
         <p:spPr>
           <a:xfrm>
             <a:off x="0" y="0"/>
-            <a:ext cx="2971800" cy="457200"/>
+            <a:ext cx="2971800" cy="458788"/>
           </a:xfrm>
           <a:prstGeom prst="rect">
             <a:avLst/>
@@ -185,7 +204,7 @@
         <p:spPr>
           <a:xfrm>
             <a:off x="3884613" y="0"/>
-            <a:ext cx="2971800" cy="457200"/>
+            <a:ext cx="2971800" cy="458788"/>
           </a:xfrm>
           <a:prstGeom prst="rect">
             <a:avLst/>
@@ -199,9 +218,9 @@
             </a:lvl1pPr>
           </a:lstStyle>
           <a:p>
-            <a:fld id="{0F89C1C7-3DCD-1040-A9CF-14679D8B5DDD}" type="datetimeFigureOut">
+            <a:fld id="{204AB913-94B9-496C-9424-68F90588AF6F}" type="datetimeFigureOut">
               <a:rPr lang="en-US" smtClean="0"/>
-              <a:t>10/17/16</a:t>
+              <a:t>9/17/2026</a:t>
             </a:fld>
             <a:endParaRPr lang="en-US"/>
           </a:p>
@@ -219,8 +238,8 @@
         </p:nvSpPr>
         <p:spPr>
           <a:xfrm>
-            <a:off x="1143000" y="685800"/>
-            <a:ext cx="4572000" cy="3429000"/>
+            <a:off x="685800" y="1143000"/>
+            <a:ext cx="5486400" cy="3086100"/>
           </a:xfrm>
           <a:prstGeom prst="rect">
             <a:avLst/>
@@ -252,8 +271,8 @@
         </p:nvSpPr>
         <p:spPr>
           <a:xfrm>
-            <a:off x="685800" y="4343400"/>
-            <a:ext cx="5486400" cy="4114800"/>
+            <a:off x="685800" y="4400550"/>
+            <a:ext cx="5486400" cy="3600450"/>
           </a:xfrm>
           <a:prstGeom prst="rect">
             <a:avLst/>
@@ -265,38 +284,37 @@
           <a:p>
             <a:pPr lvl="0"/>
             <a:r>
-              <a:rPr lang="en-US" smtClean="0"/>
+              <a:rPr lang="en-US"/>
               <a:t>Click to edit Master text styles</a:t>
             </a:r>
           </a:p>
           <a:p>
             <a:pPr lvl="1"/>
             <a:r>
-              <a:rPr lang="en-US" smtClean="0"/>
+              <a:rPr lang="en-US"/>
               <a:t>Second level</a:t>
             </a:r>
           </a:p>
           <a:p>
             <a:pPr lvl="2"/>
             <a:r>
-              <a:rPr lang="en-US" smtClean="0"/>
+              <a:rPr lang="en-US"/>
               <a:t>Third level</a:t>
             </a:r>
           </a:p>
           <a:p>
             <a:pPr lvl="3"/>
             <a:r>
-              <a:rPr lang="en-US" smtClean="0"/>
+              <a:rPr lang="en-US"/>
               <a:t>Fourth level</a:t>
             </a:r>
           </a:p>
           <a:p>
             <a:pPr lvl="4"/>
             <a:r>
-              <a:rPr lang="en-US" smtClean="0"/>
+              <a:rPr lang="en-US"/>
               <a:t>Fifth level</a:t>
             </a:r>
-            <a:endParaRPr lang="en-US"/>
           </a:p>
         </p:txBody>
       </p:sp>
@@ -313,7 +331,7 @@
         <p:spPr>
           <a:xfrm>
             <a:off x="0" y="8685213"/>
-            <a:ext cx="2971800" cy="457200"/>
+            <a:ext cx="2971800" cy="458787"/>
           </a:xfrm>
           <a:prstGeom prst="rect">
             <a:avLst/>
@@ -344,7 +362,7 @@
         <p:spPr>
           <a:xfrm>
             <a:off x="3884613" y="8685213"/>
-            <a:ext cx="2971800" cy="457200"/>
+            <a:ext cx="2971800" cy="458787"/>
           </a:xfrm>
           <a:prstGeom prst="rect">
             <a:avLst/>
@@ -358,7 +376,7 @@
             </a:lvl1pPr>
           </a:lstStyle>
           <a:p>
-            <a:fld id="{BB5E49A5-4136-284D-997B-48E1D791AD67}" type="slidenum">
+            <a:fld id="{95120817-17AE-4068-8CDC-6652498FB33C}" type="slidenum">
               <a:rPr lang="en-US" smtClean="0"/>
               <a:t>‹#›</a:t>
             </a:fld>
@@ -369,13 +387,13 @@
     </p:spTree>
     <p:extLst>
       <p:ext uri="{BB962C8B-B14F-4D97-AF65-F5344CB8AC3E}">
-        <p14:creationId xmlns:p14="http://schemas.microsoft.com/office/powerpoint/2010/main" val="2623252185"/>
+        <p14:creationId xmlns:p14="http://schemas.microsoft.com/office/powerpoint/2010/main" val="737203679"/>
       </p:ext>
     </p:extLst>
   </p:cSld>
   <p:clrMap bg1="lt1" tx1="dk1" bg2="lt2" tx2="dk2" accent1="accent1" accent2="accent2" accent3="accent3" accent4="accent4" accent5="accent5" accent6="accent6" hlink="hlink" folHlink="folHlink"/>
   <p:notesStyle>
-    <a:lvl1pPr marL="0" algn="l" defTabSz="457200" rtl="0" eaLnBrk="1" latinLnBrk="0" hangingPunct="1">
+    <a:lvl1pPr marL="0" algn="l" defTabSz="914400" rtl="0" eaLnBrk="1" latinLnBrk="0" hangingPunct="1">
       <a:defRPr sz="1200" kern="1200">
         <a:solidFill>
           <a:schemeClr val="tx1"/>
@@ -385,7 +403,7 @@
         <a:cs typeface="+mn-cs"/>
       </a:defRPr>
     </a:lvl1pPr>
-    <a:lvl2pPr marL="457200" algn="l" defTabSz="457200" rtl="0" eaLnBrk="1" latinLnBrk="0" hangingPunct="1">
+    <a:lvl2pPr marL="457200" algn="l" defTabSz="914400" rtl="0" eaLnBrk="1" latinLnBrk="0" hangingPunct="1">
       <a:defRPr sz="1200" kern="1200">
         <a:solidFill>
           <a:schemeClr val="tx1"/>
@@ -395,7 +413,7 @@
         <a:cs typeface="+mn-cs"/>
       </a:defRPr>
     </a:lvl2pPr>
-    <a:lvl3pPr marL="914400" algn="l" defTabSz="457200" rtl="0" eaLnBrk="1" latinLnBrk="0" hangingPunct="1">
+    <a:lvl3pPr marL="914400" algn="l" defTabSz="914400" rtl="0" eaLnBrk="1" latinLnBrk="0" hangingPunct="1">
       <a:defRPr sz="1200" kern="1200">
         <a:solidFill>
           <a:schemeClr val="tx1"/>
@@ -405,7 +423,7 @@
         <a:cs typeface="+mn-cs"/>
       </a:defRPr>
     </a:lvl3pPr>
-    <a:lvl4pPr marL="1371600" algn="l" defTabSz="457200" rtl="0" eaLnBrk="1" latinLnBrk="0" hangingPunct="1">
+    <a:lvl4pPr marL="1371600" algn="l" defTabSz="914400" rtl="0" eaLnBrk="1" latinLnBrk="0" hangingPunct="1">
       <a:defRPr sz="1200" kern="1200">
         <a:solidFill>
           <a:schemeClr val="tx1"/>
@@ -415,7 +433,7 @@
         <a:cs typeface="+mn-cs"/>
       </a:defRPr>
     </a:lvl4pPr>
-    <a:lvl5pPr marL="1828800" algn="l" defTabSz="457200" rtl="0" eaLnBrk="1" latinLnBrk="0" hangingPunct="1">
+    <a:lvl5pPr marL="1828800" algn="l" defTabSz="914400" rtl="0" eaLnBrk="1" latinLnBrk="0" hangingPunct="1">
       <a:defRPr sz="1200" kern="1200">
         <a:solidFill>
           <a:schemeClr val="tx1"/>
@@ -425,7 +443,7 @@
         <a:cs typeface="+mn-cs"/>
       </a:defRPr>
     </a:lvl5pPr>
-    <a:lvl6pPr marL="2286000" algn="l" defTabSz="457200" rtl="0" eaLnBrk="1" latinLnBrk="0" hangingPunct="1">
+    <a:lvl6pPr marL="2286000" algn="l" defTabSz="914400" rtl="0" eaLnBrk="1" latinLnBrk="0" hangingPunct="1">
       <a:defRPr sz="1200" kern="1200">
         <a:solidFill>
           <a:schemeClr val="tx1"/>
@@ -435,7 +453,7 @@
         <a:cs typeface="+mn-cs"/>
       </a:defRPr>
     </a:lvl6pPr>
-    <a:lvl7pPr marL="2743200" algn="l" defTabSz="457200" rtl="0" eaLnBrk="1" latinLnBrk="0" hangingPunct="1">
+    <a:lvl7pPr marL="2743200" algn="l" defTabSz="914400" rtl="0" eaLnBrk="1" latinLnBrk="0" hangingPunct="1">
       <a:defRPr sz="1200" kern="1200">
         <a:solidFill>
           <a:schemeClr val="tx1"/>
@@ -445,7 +463,7 @@
         <a:cs typeface="+mn-cs"/>
       </a:defRPr>
     </a:lvl7pPr>
-    <a:lvl8pPr marL="3200400" algn="l" defTabSz="457200" rtl="0" eaLnBrk="1" latinLnBrk="0" hangingPunct="1">
+    <a:lvl8pPr marL="3200400" algn="l" defTabSz="914400" rtl="0" eaLnBrk="1" latinLnBrk="0" hangingPunct="1">
       <a:defRPr sz="1200" kern="1200">
         <a:solidFill>
           <a:schemeClr val="tx1"/>
@@ -455,7 +473,7 @@
         <a:cs typeface="+mn-cs"/>
       </a:defRPr>
     </a:lvl8pPr>
-    <a:lvl9pPr marL="3657600" algn="l" defTabSz="457200" rtl="0" eaLnBrk="1" latinLnBrk="0" hangingPunct="1">
+    <a:lvl9pPr marL="3657600" algn="l" defTabSz="914400" rtl="0" eaLnBrk="1" latinLnBrk="0" hangingPunct="1">
       <a:defRPr sz="1200" kern="1200">
         <a:solidFill>
           <a:schemeClr val="tx1"/>
@@ -470,7 +488,7 @@
 </file>
 
 <file path=ppt/notesSlides/notesSlide1.xml><?xml version="1.0" encoding="utf-8"?>
-<p:notes xmlns:a="http://schemas.openxmlformats.org/drawingml/2006/main" xmlns:p="http://schemas.openxmlformats.org/presentationml/2006/main" xmlns:r="http://schemas.openxmlformats.org/officeDocument/2006/relationships">
+<p:notes xmlns:a="http://schemas.openxmlformats.org/drawingml/2006/main" xmlns:r="http://schemas.openxmlformats.org/officeDocument/2006/relationships" xmlns:p="http://schemas.openxmlformats.org/presentationml/2006/main">
   <p:cSld>
     <p:spTree>
       <p:nvGrpSpPr>
@@ -490,7 +508,7 @@
         <p:nvSpPr>
           <p:cNvPr id="2" name="Slide Image Placeholder 1"/>
           <p:cNvSpPr>
-            <a:spLocks noGrp="1"/>
+            <a:spLocks noGrp="1" noRot="1" noChangeAspect="1"/>
           </p:cNvSpPr>
           <p:nvPr>
             <p:ph type="sldImg" idx="2"/>
@@ -505,7 +523,7 @@
             <a:spLocks noGrp="1"/>
           </p:cNvSpPr>
           <p:nvPr>
-            <p:ph type="body" idx="3" sz="quarter"/>
+            <p:ph type="body" sz="quarter" idx="3"/>
           </p:nvPr>
         </p:nvSpPr>
         <p:spPr/>
@@ -526,7 +544,7 @@
             <a:spLocks noGrp="1"/>
           </p:cNvSpPr>
           <p:nvPr>
-            <p:ph type="sldNum" idx="5" sz="quarter"/>
+            <p:ph type="sldNum" sz="quarter" idx="5"/>
           </p:nvPr>
         </p:nvSpPr>
         <p:spPr/>
@@ -540,7 +558,7 @@
 </file>
 
 <file path=ppt/notesSlides/notesSlide2.xml><?xml version="1.0" encoding="utf-8"?>
-<p:notes xmlns:a="http://schemas.openxmlformats.org/drawingml/2006/main" xmlns:p="http://schemas.openxmlformats.org/presentationml/2006/main" xmlns:r="http://schemas.openxmlformats.org/officeDocument/2006/relationships">
+<p:notes xmlns:a="http://schemas.openxmlformats.org/drawingml/2006/main" xmlns:r="http://schemas.openxmlformats.org/officeDocument/2006/relationships" xmlns:p="http://schemas.openxmlformats.org/presentationml/2006/main">
   <p:cSld>
     <p:spTree>
       <p:nvGrpSpPr>
@@ -560,7 +578,7 @@
         <p:nvSpPr>
           <p:cNvPr id="2" name="Slide Image Placeholder 1"/>
           <p:cNvSpPr>
-            <a:spLocks noGrp="1"/>
+            <a:spLocks noGrp="1" noRot="1" noChangeAspect="1"/>
           </p:cNvSpPr>
           <p:nvPr>
             <p:ph type="sldImg" idx="2"/>
@@ -575,7 +593,7 @@
             <a:spLocks noGrp="1"/>
           </p:cNvSpPr>
           <p:nvPr>
-            <p:ph type="body" idx="3" sz="quarter"/>
+            <p:ph type="body" sz="quarter" idx="3"/>
           </p:nvPr>
         </p:nvSpPr>
         <p:spPr/>
@@ -596,7 +614,7 @@
             <a:spLocks noGrp="1"/>
           </p:cNvSpPr>
           <p:nvPr>
-            <p:ph type="sldNum" idx="5" sz="quarter"/>
+            <p:ph type="sldNum" sz="quarter" idx="5"/>
           </p:nvPr>
         </p:nvSpPr>
         <p:spPr/>
@@ -610,7 +628,7 @@
 </file>
 
 <file path=ppt/notesSlides/notesSlide3.xml><?xml version="1.0" encoding="utf-8"?>
-<p:notes xmlns:a="http://schemas.openxmlformats.org/drawingml/2006/main" xmlns:p="http://schemas.openxmlformats.org/presentationml/2006/main" xmlns:r="http://schemas.openxmlformats.org/officeDocument/2006/relationships">
+<p:notes xmlns:a="http://schemas.openxmlformats.org/drawingml/2006/main" xmlns:r="http://schemas.openxmlformats.org/officeDocument/2006/relationships" xmlns:p="http://schemas.openxmlformats.org/presentationml/2006/main">
   <p:cSld>
     <p:spTree>
       <p:nvGrpSpPr>
@@ -630,7 +648,7 @@
         <p:nvSpPr>
           <p:cNvPr id="2" name="Slide Image Placeholder 1"/>
           <p:cNvSpPr>
-            <a:spLocks noGrp="1"/>
+            <a:spLocks noGrp="1" noRot="1" noChangeAspect="1"/>
           </p:cNvSpPr>
           <p:nvPr>
             <p:ph type="sldImg" idx="2"/>
@@ -645,7 +663,7 @@
             <a:spLocks noGrp="1"/>
           </p:cNvSpPr>
           <p:nvPr>
-            <p:ph type="body" idx="3" sz="quarter"/>
+            <p:ph type="body" sz="quarter" idx="3"/>
           </p:nvPr>
         </p:nvSpPr>
         <p:spPr/>
@@ -666,7 +684,7 @@
             <a:spLocks noGrp="1"/>
           </p:cNvSpPr>
           <p:nvPr>
-            <p:ph type="sldNum" idx="5" sz="quarter"/>
+            <p:ph type="sldNum" sz="quarter" idx="5"/>
           </p:nvPr>
         </p:nvSpPr>
         <p:spPr/>
@@ -717,10 +735,9 @@
           <a:lstStyle/>
           <a:p>
             <a:r>
-              <a:rPr lang="en-US" smtClean="0"/>
+              <a:rPr lang="en-US"/>
               <a:t>Click to edit Master title style</a:t>
             </a:r>
-            <a:endParaRPr lang="en-US"/>
           </a:p>
         </p:txBody>
       </p:sp>
@@ -836,10 +853,9 @@
           </a:lstStyle>
           <a:p>
             <a:r>
-              <a:rPr lang="en-US" smtClean="0"/>
+              <a:rPr lang="en-US"/>
               <a:t>Click to edit Master subtitle style</a:t>
             </a:r>
-            <a:endParaRPr lang="en-US"/>
           </a:p>
         </p:txBody>
       </p:sp>
@@ -860,7 +876,7 @@
           <a:p>
             <a:fld id="{5BCAD085-E8A6-8845-BD4E-CB4CCA059FC4}" type="datetimeFigureOut">
               <a:rPr lang="en-US" smtClean="0"/>
-              <a:t>1/27/13</a:t>
+              <a:t>9/17/2026</a:t>
             </a:fld>
             <a:endParaRPr lang="en-US"/>
           </a:p>
@@ -954,10 +970,9 @@
           <a:lstStyle/>
           <a:p>
             <a:r>
-              <a:rPr lang="en-US" smtClean="0"/>
+              <a:rPr lang="en-US"/>
               <a:t>Click to edit Master title style</a:t>
             </a:r>
-            <a:endParaRPr lang="en-US"/>
           </a:p>
         </p:txBody>
       </p:sp>
@@ -978,38 +993,37 @@
           <a:p>
             <a:pPr lvl="0"/>
             <a:r>
-              <a:rPr lang="en-US" smtClean="0"/>
+              <a:rPr lang="en-US"/>
               <a:t>Click to edit Master text styles</a:t>
             </a:r>
           </a:p>
           <a:p>
             <a:pPr lvl="1"/>
             <a:r>
-              <a:rPr lang="en-US" smtClean="0"/>
+              <a:rPr lang="en-US"/>
               <a:t>Second level</a:t>
             </a:r>
           </a:p>
           <a:p>
             <a:pPr lvl="2"/>
             <a:r>
-              <a:rPr lang="en-US" smtClean="0"/>
+              <a:rPr lang="en-US"/>
               <a:t>Third level</a:t>
             </a:r>
           </a:p>
           <a:p>
             <a:pPr lvl="3"/>
             <a:r>
-              <a:rPr lang="en-US" smtClean="0"/>
+              <a:rPr lang="en-US"/>
               <a:t>Fourth level</a:t>
             </a:r>
           </a:p>
           <a:p>
             <a:pPr lvl="4"/>
             <a:r>
-              <a:rPr lang="en-US" smtClean="0"/>
+              <a:rPr lang="en-US"/>
               <a:t>Fifth level</a:t>
             </a:r>
-            <a:endParaRPr lang="en-US"/>
           </a:p>
         </p:txBody>
       </p:sp>
@@ -1030,7 +1044,7 @@
           <a:p>
             <a:fld id="{5BCAD085-E8A6-8845-BD4E-CB4CCA059FC4}" type="datetimeFigureOut">
               <a:rPr lang="en-US" smtClean="0"/>
-              <a:t>1/27/13</a:t>
+              <a:t>9/17/2026</a:t>
             </a:fld>
             <a:endParaRPr lang="en-US"/>
           </a:p>
@@ -1129,10 +1143,9 @@
           <a:lstStyle/>
           <a:p>
             <a:r>
-              <a:rPr lang="en-US" smtClean="0"/>
+              <a:rPr lang="en-US"/>
               <a:t>Click to edit Master title style</a:t>
             </a:r>
-            <a:endParaRPr lang="en-US"/>
           </a:p>
         </p:txBody>
       </p:sp>
@@ -1158,38 +1171,37 @@
           <a:p>
             <a:pPr lvl="0"/>
             <a:r>
-              <a:rPr lang="en-US" smtClean="0"/>
+              <a:rPr lang="en-US"/>
               <a:t>Click to edit Master text styles</a:t>
             </a:r>
           </a:p>
           <a:p>
             <a:pPr lvl="1"/>
             <a:r>
-              <a:rPr lang="en-US" smtClean="0"/>
+              <a:rPr lang="en-US"/>
               <a:t>Second level</a:t>
             </a:r>
           </a:p>
           <a:p>
             <a:pPr lvl="2"/>
             <a:r>
-              <a:rPr lang="en-US" smtClean="0"/>
+              <a:rPr lang="en-US"/>
               <a:t>Third level</a:t>
             </a:r>
           </a:p>
           <a:p>
             <a:pPr lvl="3"/>
             <a:r>
-              <a:rPr lang="en-US" smtClean="0"/>
+              <a:rPr lang="en-US"/>
               <a:t>Fourth level</a:t>
             </a:r>
           </a:p>
           <a:p>
             <a:pPr lvl="4"/>
             <a:r>
-              <a:rPr lang="en-US" smtClean="0"/>
+              <a:rPr lang="en-US"/>
               <a:t>Fifth level</a:t>
             </a:r>
-            <a:endParaRPr lang="en-US"/>
           </a:p>
         </p:txBody>
       </p:sp>
@@ -1210,7 +1222,7 @@
           <a:p>
             <a:fld id="{5BCAD085-E8A6-8845-BD4E-CB4CCA059FC4}" type="datetimeFigureOut">
               <a:rPr lang="en-US" smtClean="0"/>
-              <a:t>1/27/13</a:t>
+              <a:t>9/17/2026</a:t>
             </a:fld>
             <a:endParaRPr lang="en-US"/>
           </a:p>
@@ -1304,10 +1316,9 @@
           <a:lstStyle/>
           <a:p>
             <a:r>
-              <a:rPr lang="en-US" smtClean="0"/>
+              <a:rPr lang="en-US"/>
               <a:t>Click to edit Master title style</a:t>
             </a:r>
-            <a:endParaRPr lang="en-US"/>
           </a:p>
         </p:txBody>
       </p:sp>
@@ -1328,38 +1339,37 @@
           <a:p>
             <a:pPr lvl="0"/>
             <a:r>
-              <a:rPr lang="en-US" smtClean="0"/>
+              <a:rPr lang="en-US"/>
               <a:t>Click to edit Master text styles</a:t>
             </a:r>
           </a:p>
           <a:p>
             <a:pPr lvl="1"/>
             <a:r>
-              <a:rPr lang="en-US" smtClean="0"/>
+              <a:rPr lang="en-US"/>
               <a:t>Second level</a:t>
             </a:r>
           </a:p>
           <a:p>
             <a:pPr lvl="2"/>
             <a:r>
-              <a:rPr lang="en-US" smtClean="0"/>
+              <a:rPr lang="en-US"/>
               <a:t>Third level</a:t>
             </a:r>
           </a:p>
           <a:p>
             <a:pPr lvl="3"/>
             <a:r>
-              <a:rPr lang="en-US" smtClean="0"/>
+              <a:rPr lang="en-US"/>
               <a:t>Fourth level</a:t>
             </a:r>
           </a:p>
           <a:p>
             <a:pPr lvl="4"/>
             <a:r>
-              <a:rPr lang="en-US" smtClean="0"/>
+              <a:rPr lang="en-US"/>
               <a:t>Fifth level</a:t>
             </a:r>
-            <a:endParaRPr lang="en-US"/>
           </a:p>
         </p:txBody>
       </p:sp>
@@ -1380,7 +1390,7 @@
           <a:p>
             <a:fld id="{5BCAD085-E8A6-8845-BD4E-CB4CCA059FC4}" type="datetimeFigureOut">
               <a:rPr lang="en-US" smtClean="0"/>
-              <a:t>1/27/13</a:t>
+              <a:t>9/17/2026</a:t>
             </a:fld>
             <a:endParaRPr lang="en-US"/>
           </a:p>
@@ -1483,10 +1493,9 @@
           </a:lstStyle>
           <a:p>
             <a:r>
-              <a:rPr lang="en-US" smtClean="0"/>
+              <a:rPr lang="en-US"/>
               <a:t>Click to edit Master title style</a:t>
             </a:r>
-            <a:endParaRPr lang="en-US"/>
           </a:p>
         </p:txBody>
       </p:sp>
@@ -1603,7 +1612,7 @@
           <a:p>
             <a:pPr lvl="0"/>
             <a:r>
-              <a:rPr lang="en-US" smtClean="0"/>
+              <a:rPr lang="en-US"/>
               <a:t>Click to edit Master text styles</a:t>
             </a:r>
           </a:p>
@@ -1626,7 +1635,7 @@
           <a:p>
             <a:fld id="{5BCAD085-E8A6-8845-BD4E-CB4CCA059FC4}" type="datetimeFigureOut">
               <a:rPr lang="en-US" smtClean="0"/>
-              <a:t>1/27/13</a:t>
+              <a:t>9/17/2026</a:t>
             </a:fld>
             <a:endParaRPr lang="en-US"/>
           </a:p>
@@ -1720,10 +1729,9 @@
           <a:lstStyle/>
           <a:p>
             <a:r>
-              <a:rPr lang="en-US" smtClean="0"/>
+              <a:rPr lang="en-US"/>
               <a:t>Click to edit Master title style</a:t>
             </a:r>
-            <a:endParaRPr lang="en-US"/>
           </a:p>
         </p:txBody>
       </p:sp>
@@ -1777,38 +1785,37 @@
           <a:p>
             <a:pPr lvl="0"/>
             <a:r>
-              <a:rPr lang="en-US" smtClean="0"/>
+              <a:rPr lang="en-US"/>
               <a:t>Click to edit Master text styles</a:t>
             </a:r>
           </a:p>
           <a:p>
             <a:pPr lvl="1"/>
             <a:r>
-              <a:rPr lang="en-US" smtClean="0"/>
+              <a:rPr lang="en-US"/>
               <a:t>Second level</a:t>
             </a:r>
           </a:p>
           <a:p>
             <a:pPr lvl="2"/>
             <a:r>
-              <a:rPr lang="en-US" smtClean="0"/>
+              <a:rPr lang="en-US"/>
               <a:t>Third level</a:t>
             </a:r>
           </a:p>
           <a:p>
             <a:pPr lvl="3"/>
             <a:r>
-              <a:rPr lang="en-US" smtClean="0"/>
+              <a:rPr lang="en-US"/>
               <a:t>Fourth level</a:t>
             </a:r>
           </a:p>
           <a:p>
             <a:pPr lvl="4"/>
             <a:r>
-              <a:rPr lang="en-US" smtClean="0"/>
+              <a:rPr lang="en-US"/>
               <a:t>Fifth level</a:t>
             </a:r>
-            <a:endParaRPr lang="en-US"/>
           </a:p>
         </p:txBody>
       </p:sp>
@@ -1862,38 +1869,37 @@
           <a:p>
             <a:pPr lvl="0"/>
             <a:r>
-              <a:rPr lang="en-US" smtClean="0"/>
+              <a:rPr lang="en-US"/>
               <a:t>Click to edit Master text styles</a:t>
             </a:r>
           </a:p>
           <a:p>
             <a:pPr lvl="1"/>
             <a:r>
-              <a:rPr lang="en-US" smtClean="0"/>
+              <a:rPr lang="en-US"/>
               <a:t>Second level</a:t>
             </a:r>
           </a:p>
           <a:p>
             <a:pPr lvl="2"/>
             <a:r>
-              <a:rPr lang="en-US" smtClean="0"/>
+              <a:rPr lang="en-US"/>
               <a:t>Third level</a:t>
             </a:r>
           </a:p>
           <a:p>
             <a:pPr lvl="3"/>
             <a:r>
-              <a:rPr lang="en-US" smtClean="0"/>
+              <a:rPr lang="en-US"/>
               <a:t>Fourth level</a:t>
             </a:r>
           </a:p>
           <a:p>
             <a:pPr lvl="4"/>
             <a:r>
-              <a:rPr lang="en-US" smtClean="0"/>
+              <a:rPr lang="en-US"/>
               <a:t>Fifth level</a:t>
             </a:r>
-            <a:endParaRPr lang="en-US"/>
           </a:p>
         </p:txBody>
       </p:sp>
@@ -1914,7 +1920,7 @@
           <a:p>
             <a:fld id="{5BCAD085-E8A6-8845-BD4E-CB4CCA059FC4}" type="datetimeFigureOut">
               <a:rPr lang="en-US" smtClean="0"/>
-              <a:t>1/27/13</a:t>
+              <a:t>9/17/2026</a:t>
             </a:fld>
             <a:endParaRPr lang="en-US"/>
           </a:p>
@@ -2012,10 +2018,9 @@
           </a:lstStyle>
           <a:p>
             <a:r>
-              <a:rPr lang="en-US" smtClean="0"/>
+              <a:rPr lang="en-US"/>
               <a:t>Click to edit Master title style</a:t>
             </a:r>
-            <a:endParaRPr lang="en-US"/>
           </a:p>
         </p:txBody>
       </p:sp>
@@ -2078,7 +2083,7 @@
           <a:p>
             <a:pPr lvl="0"/>
             <a:r>
-              <a:rPr lang="en-US" smtClean="0"/>
+              <a:rPr lang="en-US"/>
               <a:t>Click to edit Master text styles</a:t>
             </a:r>
           </a:p>
@@ -2134,38 +2139,37 @@
           <a:p>
             <a:pPr lvl="0"/>
             <a:r>
-              <a:rPr lang="en-US" smtClean="0"/>
+              <a:rPr lang="en-US"/>
               <a:t>Click to edit Master text styles</a:t>
             </a:r>
           </a:p>
           <a:p>
             <a:pPr lvl="1"/>
             <a:r>
-              <a:rPr lang="en-US" smtClean="0"/>
+              <a:rPr lang="en-US"/>
               <a:t>Second level</a:t>
             </a:r>
           </a:p>
           <a:p>
             <a:pPr lvl="2"/>
             <a:r>
-              <a:rPr lang="en-US" smtClean="0"/>
+              <a:rPr lang="en-US"/>
               <a:t>Third level</a:t>
             </a:r>
           </a:p>
           <a:p>
             <a:pPr lvl="3"/>
             <a:r>
-              <a:rPr lang="en-US" smtClean="0"/>
+              <a:rPr lang="en-US"/>
               <a:t>Fourth level</a:t>
             </a:r>
           </a:p>
           <a:p>
             <a:pPr lvl="4"/>
             <a:r>
-              <a:rPr lang="en-US" smtClean="0"/>
+              <a:rPr lang="en-US"/>
               <a:t>Fifth level</a:t>
             </a:r>
-            <a:endParaRPr lang="en-US"/>
           </a:p>
         </p:txBody>
       </p:sp>
@@ -2228,7 +2232,7 @@
           <a:p>
             <a:pPr lvl="0"/>
             <a:r>
-              <a:rPr lang="en-US" smtClean="0"/>
+              <a:rPr lang="en-US"/>
               <a:t>Click to edit Master text styles</a:t>
             </a:r>
           </a:p>
@@ -2284,38 +2288,37 @@
           <a:p>
             <a:pPr lvl="0"/>
             <a:r>
-              <a:rPr lang="en-US" smtClean="0"/>
+              <a:rPr lang="en-US"/>
               <a:t>Click to edit Master text styles</a:t>
             </a:r>
           </a:p>
           <a:p>
             <a:pPr lvl="1"/>
             <a:r>
-              <a:rPr lang="en-US" smtClean="0"/>
+              <a:rPr lang="en-US"/>
               <a:t>Second level</a:t>
             </a:r>
           </a:p>
           <a:p>
             <a:pPr lvl="2"/>
             <a:r>
-              <a:rPr lang="en-US" smtClean="0"/>
+              <a:rPr lang="en-US"/>
               <a:t>Third level</a:t>
             </a:r>
           </a:p>
           <a:p>
             <a:pPr lvl="3"/>
             <a:r>
-              <a:rPr lang="en-US" smtClean="0"/>
+              <a:rPr lang="en-US"/>
               <a:t>Fourth level</a:t>
             </a:r>
           </a:p>
           <a:p>
             <a:pPr lvl="4"/>
             <a:r>
-              <a:rPr lang="en-US" smtClean="0"/>
+              <a:rPr lang="en-US"/>
               <a:t>Fifth level</a:t>
             </a:r>
-            <a:endParaRPr lang="en-US"/>
           </a:p>
         </p:txBody>
       </p:sp>
@@ -2336,7 +2339,7 @@
           <a:p>
             <a:fld id="{5BCAD085-E8A6-8845-BD4E-CB4CCA059FC4}" type="datetimeFigureOut">
               <a:rPr lang="en-US" smtClean="0"/>
-              <a:t>1/27/13</a:t>
+              <a:t>9/17/2026</a:t>
             </a:fld>
             <a:endParaRPr lang="en-US"/>
           </a:p>
@@ -2430,10 +2433,9 @@
           <a:lstStyle/>
           <a:p>
             <a:r>
-              <a:rPr lang="en-US" smtClean="0"/>
+              <a:rPr lang="en-US"/>
               <a:t>Click to edit Master title style</a:t>
             </a:r>
-            <a:endParaRPr lang="en-US"/>
           </a:p>
         </p:txBody>
       </p:sp>
@@ -2454,7 +2456,7 @@
           <a:p>
             <a:fld id="{5BCAD085-E8A6-8845-BD4E-CB4CCA059FC4}" type="datetimeFigureOut">
               <a:rPr lang="en-US" smtClean="0"/>
-              <a:t>1/27/13</a:t>
+              <a:t>9/17/2026</a:t>
             </a:fld>
             <a:endParaRPr lang="en-US"/>
           </a:p>
@@ -2549,7 +2551,7 @@
           <a:p>
             <a:fld id="{5BCAD085-E8A6-8845-BD4E-CB4CCA059FC4}" type="datetimeFigureOut">
               <a:rPr lang="en-US" smtClean="0"/>
-              <a:t>1/27/13</a:t>
+              <a:t>9/17/2026</a:t>
             </a:fld>
             <a:endParaRPr lang="en-US"/>
           </a:p>
@@ -2652,10 +2654,9 @@
           </a:lstStyle>
           <a:p>
             <a:r>
-              <a:rPr lang="en-US" smtClean="0"/>
+              <a:rPr lang="en-US"/>
               <a:t>Click to edit Master title style</a:t>
             </a:r>
-            <a:endParaRPr lang="en-US"/>
           </a:p>
         </p:txBody>
       </p:sp>
@@ -2709,38 +2710,37 @@
           <a:p>
             <a:pPr lvl="0"/>
             <a:r>
-              <a:rPr lang="en-US" smtClean="0"/>
+              <a:rPr lang="en-US"/>
               <a:t>Click to edit Master text styles</a:t>
             </a:r>
           </a:p>
           <a:p>
             <a:pPr lvl="1"/>
             <a:r>
-              <a:rPr lang="en-US" smtClean="0"/>
+              <a:rPr lang="en-US"/>
               <a:t>Second level</a:t>
             </a:r>
           </a:p>
           <a:p>
             <a:pPr lvl="2"/>
             <a:r>
-              <a:rPr lang="en-US" smtClean="0"/>
+              <a:rPr lang="en-US"/>
               <a:t>Third level</a:t>
             </a:r>
           </a:p>
           <a:p>
             <a:pPr lvl="3"/>
             <a:r>
-              <a:rPr lang="en-US" smtClean="0"/>
+              <a:rPr lang="en-US"/>
               <a:t>Fourth level</a:t>
             </a:r>
           </a:p>
           <a:p>
             <a:pPr lvl="4"/>
             <a:r>
-              <a:rPr lang="en-US" smtClean="0"/>
+              <a:rPr lang="en-US"/>
               <a:t>Fifth level</a:t>
             </a:r>
-            <a:endParaRPr lang="en-US"/>
           </a:p>
         </p:txBody>
       </p:sp>
@@ -2803,7 +2803,7 @@
           <a:p>
             <a:pPr lvl="0"/>
             <a:r>
-              <a:rPr lang="en-US" smtClean="0"/>
+              <a:rPr lang="en-US"/>
               <a:t>Click to edit Master text styles</a:t>
             </a:r>
           </a:p>
@@ -2826,7 +2826,7 @@
           <a:p>
             <a:fld id="{5BCAD085-E8A6-8845-BD4E-CB4CCA059FC4}" type="datetimeFigureOut">
               <a:rPr lang="en-US" smtClean="0"/>
-              <a:t>1/27/13</a:t>
+              <a:t>9/17/2026</a:t>
             </a:fld>
             <a:endParaRPr lang="en-US"/>
           </a:p>
@@ -2929,10 +2929,9 @@
           </a:lstStyle>
           <a:p>
             <a:r>
-              <a:rPr lang="en-US" smtClean="0"/>
+              <a:rPr lang="en-US"/>
               <a:t>Click to edit Master title style</a:t>
             </a:r>
-            <a:endParaRPr lang="en-US"/>
           </a:p>
         </p:txBody>
       </p:sp>
@@ -3056,7 +3055,7 @@
           <a:p>
             <a:pPr lvl="0"/>
             <a:r>
-              <a:rPr lang="en-US" smtClean="0"/>
+              <a:rPr lang="en-US"/>
               <a:t>Click to edit Master text styles</a:t>
             </a:r>
           </a:p>
@@ -3079,7 +3078,7 @@
           <a:p>
             <a:fld id="{5BCAD085-E8A6-8845-BD4E-CB4CCA059FC4}" type="datetimeFigureOut">
               <a:rPr lang="en-US" smtClean="0"/>
-              <a:t>1/27/13</a:t>
+              <a:t>9/17/2026</a:t>
             </a:fld>
             <a:endParaRPr lang="en-US"/>
           </a:p>
@@ -3188,10 +3187,9 @@
           <a:lstStyle/>
           <a:p>
             <a:r>
-              <a:rPr lang="en-US" smtClean="0"/>
+              <a:rPr lang="en-US"/>
               <a:t>Click to edit Master title style</a:t>
             </a:r>
-            <a:endParaRPr lang="en-US"/>
           </a:p>
         </p:txBody>
       </p:sp>
@@ -3222,38 +3220,37 @@
           <a:p>
             <a:pPr lvl="0"/>
             <a:r>
-              <a:rPr lang="en-US" smtClean="0"/>
+              <a:rPr lang="en-US"/>
               <a:t>Click to edit Master text styles</a:t>
             </a:r>
           </a:p>
           <a:p>
             <a:pPr lvl="1"/>
             <a:r>
-              <a:rPr lang="en-US" smtClean="0"/>
+              <a:rPr lang="en-US"/>
               <a:t>Second level</a:t>
             </a:r>
           </a:p>
           <a:p>
             <a:pPr lvl="2"/>
             <a:r>
-              <a:rPr lang="en-US" smtClean="0"/>
+              <a:rPr lang="en-US"/>
               <a:t>Third level</a:t>
             </a:r>
           </a:p>
           <a:p>
             <a:pPr lvl="3"/>
             <a:r>
-              <a:rPr lang="en-US" smtClean="0"/>
+              <a:rPr lang="en-US"/>
               <a:t>Fourth level</a:t>
             </a:r>
           </a:p>
           <a:p>
             <a:pPr lvl="4"/>
             <a:r>
-              <a:rPr lang="en-US" smtClean="0"/>
+              <a:rPr lang="en-US"/>
               <a:t>Fifth level</a:t>
             </a:r>
-            <a:endParaRPr lang="en-US"/>
           </a:p>
         </p:txBody>
       </p:sp>
@@ -3292,7 +3289,7 @@
           <a:p>
             <a:fld id="{5BCAD085-E8A6-8845-BD4E-CB4CCA059FC4}" type="datetimeFigureOut">
               <a:rPr lang="en-US" smtClean="0"/>
-              <a:t>1/27/13</a:t>
+              <a:t>9/17/2026</a:t>
             </a:fld>
             <a:endParaRPr lang="en-US"/>
           </a:p>
@@ -3651,7 +3648,7 @@
 </file>
 
 <file path=ppt/slides/slide1.xml><?xml version="1.0" encoding="utf-8"?>
-<p:sld xmlns:a="http://schemas.openxmlformats.org/drawingml/2006/main" xmlns:p="http://schemas.openxmlformats.org/presentationml/2006/main" xmlns:r="http://schemas.openxmlformats.org/officeDocument/2006/relationships">
+<p:sld xmlns:a="http://schemas.openxmlformats.org/drawingml/2006/main" xmlns:r="http://schemas.openxmlformats.org/officeDocument/2006/relationships" xmlns:p="http://schemas.openxmlformats.org/presentationml/2006/main">
   <p:cSld>
     <p:spTree>
       <p:nvGrpSpPr>
@@ -3659,7 +3656,14 @@
         <p:cNvGrpSpPr/>
         <p:nvPr/>
       </p:nvGrpSpPr>
-      <p:grpSpPr/>
+      <p:grpSpPr>
+        <a:xfrm>
+          <a:off x="0" y="0"/>
+          <a:ext cx="0" cy="0"/>
+          <a:chOff x="0" y="0"/>
+          <a:chExt cx="0" cy="0"/>
+        </a:xfrm>
+      </p:grpSpPr>
       <p:sp>
         <p:nvSpPr>
           <p:cNvPr id="2" name="Title 1"/>
@@ -3711,7 +3715,7 @@
 </file>
 
 <file path=ppt/slides/slide10.xml><?xml version="1.0" encoding="utf-8"?>
-<p:sld xmlns:a="http://schemas.openxmlformats.org/drawingml/2006/main" xmlns:p="http://schemas.openxmlformats.org/presentationml/2006/main" xmlns:r="http://schemas.openxmlformats.org/officeDocument/2006/relationships">
+<p:sld xmlns:a="http://schemas.openxmlformats.org/drawingml/2006/main" xmlns:r="http://schemas.openxmlformats.org/officeDocument/2006/relationships" xmlns:p="http://schemas.openxmlformats.org/presentationml/2006/main">
   <p:cSld>
     <p:spTree>
       <p:nvGrpSpPr>
@@ -3719,7 +3723,14 @@
         <p:cNvGrpSpPr/>
         <p:nvPr/>
       </p:nvGrpSpPr>
-      <p:grpSpPr/>
+      <p:grpSpPr>
+        <a:xfrm>
+          <a:off x="0" y="0"/>
+          <a:ext cx="0" cy="0"/>
+          <a:chOff x="0" y="0"/>
+          <a:chExt cx="0" cy="0"/>
+        </a:xfrm>
+      </p:grpSpPr>
       <p:sp>
         <p:nvSpPr>
           <p:cNvPr id="2" name="Title 1"/>
@@ -3756,7 +3767,6 @@
           <a:bodyPr/>
           <a:lstStyle/>
           <a:p>
-            <a:pPr/>
             <a:r>
               <a:rPr b="1">
                 <a:solidFill>
@@ -3767,21 +3777,16 @@
             </a:r>
           </a:p>
           <a:p>
-            <a:pPr/>
-            <a:r>
-              <a:rPr/>
+            <a:r>
               <a:t>Backend returns user data nested under body['data'] in some endpoints, flat in others</a:t>
             </a:r>
           </a:p>
           <a:p>
-            <a:pPr/>
-            <a:r>
-              <a:rPr/>
+            <a:r>
               <a:t>Fix: User.fromJson() handles both — checks json['user'] nested map, falls back to top-level; tries id/userId, name/(firstName+lastName) combos</a:t>
             </a:r>
           </a:p>
           <a:p>
-            <a:pPr/>
             <a:r>
               <a:rPr b="1">
                 <a:solidFill>
@@ -3792,21 +3797,16 @@
             </a:r>
           </a:p>
           <a:p>
-            <a:pPr/>
-            <a:r>
-              <a:rPr/>
+            <a:r>
               <a:t>App needs to remember logged-in state across restarts; token must be refreshed or cleared on failure</a:t>
             </a:r>
           </a:p>
           <a:p>
-            <a:pPr/>
-            <a:r>
-              <a:rPr/>
+            <a:r>
               <a:t>Fix: SharedPreferences stores auth_token; restoreSession() in HttpAuthRepository reads it, calls /Auth/me; on AppException clears token and returns null → AuthProvider.bootstrap() sets ViewState.error</a:t>
             </a:r>
           </a:p>
           <a:p>
-            <a:pPr/>
             <a:r>
               <a:rPr b="1">
                 <a:solidFill>
@@ -3817,16 +3817,12 @@
             </a:r>
           </a:p>
           <a:p>
-            <a:pPr/>
-            <a:r>
-              <a:rPr/>
+            <a:r>
               <a:t>Raw HTTP errors don't tell UI what went wrong</a:t>
             </a:r>
           </a:p>
           <a:p>
-            <a:pPr/>
-            <a:r>
-              <a:rPr/>
+            <a:r>
               <a:t>Fix: sealed class AppException with NetworkException, UnauthorisedException, ValidationException (with fieldErrors map), TimeoutException, ServerException — each caught in AuthProvider._run() and mapped to ViewState.error + errorMessage</a:t>
             </a:r>
           </a:p>
@@ -3841,7 +3837,7 @@
 </file>
 
 <file path=ppt/slides/slide11.xml><?xml version="1.0" encoding="utf-8"?>
-<p:sld xmlns:a="http://schemas.openxmlformats.org/drawingml/2006/main" xmlns:p="http://schemas.openxmlformats.org/presentationml/2006/main" xmlns:r="http://schemas.openxmlformats.org/officeDocument/2006/relationships">
+<p:sld xmlns:a="http://schemas.openxmlformats.org/drawingml/2006/main" xmlns:r="http://schemas.openxmlformats.org/officeDocument/2006/relationships" xmlns:p="http://schemas.openxmlformats.org/presentationml/2006/main">
   <p:cSld>
     <p:spTree>
       <p:nvGrpSpPr>
@@ -3849,7 +3845,14 @@
         <p:cNvGrpSpPr/>
         <p:nvPr/>
       </p:nvGrpSpPr>
-      <p:grpSpPr/>
+      <p:grpSpPr>
+        <a:xfrm>
+          <a:off x="0" y="0"/>
+          <a:ext cx="0" cy="0"/>
+          <a:chOff x="0" y="0"/>
+          <a:chExt cx="0" cy="0"/>
+        </a:xfrm>
+      </p:grpSpPr>
       <p:sp>
         <p:nvSpPr>
           <p:cNvPr id="2" name="Title 1"/>
@@ -3886,7 +3889,6 @@
           <a:bodyPr/>
           <a:lstStyle/>
           <a:p>
-            <a:pPr/>
             <a:r>
               <a:rPr b="1">
                 <a:solidFill>
@@ -3897,21 +3899,16 @@
             </a:r>
           </a:p>
           <a:p>
-            <a:pPr/>
-            <a:r>
-              <a:rPr/>
+            <a:r>
               <a:t>Login/register/OTP all async — UI needs to show spinner and disable button during call</a:t>
             </a:r>
           </a:p>
           <a:p>
-            <a:pPr/>
-            <a:r>
-              <a:rPr/>
+            <a:r>
               <a:t>Fix: ViewState enum drives UI: loginState==ViewState.loading → ElevatedButton shows CircularProgressIndicator, onPressed=null (login_screen.dart:331-339)</a:t>
             </a:r>
           </a:p>
           <a:p>
-            <a:pPr/>
             <a:r>
               <a:rPr b="1">
                 <a:solidFill>
@@ -3922,21 +3919,16 @@
             </a:r>
           </a:p>
           <a:p>
-            <a:pPr/>
-            <a:r>
-              <a:rPr/>
+            <a:r>
               <a:t>Backend returns per-field errors (email: 'Invalid format', password: 'Too short')</a:t>
             </a:r>
           </a:p>
           <a:p>
-            <a:pPr/>
-            <a:r>
-              <a:rPr/>
+            <a:r>
               <a:t>Fix: ValidationException carries Map&lt;String,String&gt; errors; AuthProvider stores in fieldErrors; TextField errorText: auth.fieldError('email') (login_screen.dart:173,208)</a:t>
             </a:r>
           </a:p>
           <a:p>
-            <a:pPr/>
             <a:r>
               <a:rPr b="1">
                 <a:solidFill>
@@ -3947,16 +3939,12 @@
             </a:r>
           </a:p>
           <a:p>
-            <a:pPr/>
-            <a:r>
-              <a:rPr/>
+            <a:r>
               <a:t>Device biometrics (fingerprint/face) available but app needs a valid token to restore session</a:t>
             </a:r>
           </a:p>
           <a:p>
-            <a:pPr/>
-            <a:r>
-              <a:rPr/>
+            <a:r>
               <a:t>Fix: _handleBiometricLogin() checks localAuth.canCheckBiometrics → authenticates → reads stored auth_token from prefs → calls auth.bootstrap() → if isLoggedIn, pushes /home route (login_screen.dart:60-107)</a:t>
             </a:r>
           </a:p>
@@ -3971,7 +3959,7 @@
 </file>
 
 <file path=ppt/slides/slide12.xml><?xml version="1.0" encoding="utf-8"?>
-<p:sld xmlns:a="http://schemas.openxmlformats.org/drawingml/2006/main" xmlns:p="http://schemas.openxmlformats.org/presentationml/2006/main" xmlns:r="http://schemas.openxmlformats.org/officeDocument/2006/relationships">
+<p:sld xmlns:a="http://schemas.openxmlformats.org/drawingml/2006/main" xmlns:r="http://schemas.openxmlformats.org/officeDocument/2006/relationships" xmlns:p="http://schemas.openxmlformats.org/presentationml/2006/main">
   <p:cSld>
     <p:spTree>
       <p:nvGrpSpPr>
@@ -3979,7 +3967,14 @@
         <p:cNvGrpSpPr/>
         <p:nvPr/>
       </p:nvGrpSpPr>
-      <p:grpSpPr/>
+      <p:grpSpPr>
+        <a:xfrm>
+          <a:off x="0" y="0"/>
+          <a:ext cx="0" cy="0"/>
+          <a:chOff x="0" y="0"/>
+          <a:chExt cx="0" cy="0"/>
+        </a:xfrm>
+      </p:grpSpPr>
       <p:sp>
         <p:nvSpPr>
           <p:cNvPr id="2" name="Title 1"/>
@@ -4016,7 +4011,6 @@
           <a:bodyPr/>
           <a:lstStyle/>
           <a:p>
-            <a:pPr/>
             <a:r>
               <a:rPr b="1">
                 <a:solidFill>
@@ -4027,44 +4021,32 @@
             </a:r>
           </a:p>
           <a:p>
-            <a:pPr/>
-            <a:r>
-              <a:rPr/>
+            <a:r>
               <a:t>1. App launch → Tatum logo (CustomPaint 4-tile animation) → Landing screen</a:t>
             </a:r>
           </a:p>
           <a:p>
-            <a:pPr/>
-            <a:r>
-              <a:rPr/>
+            <a:r>
               <a:t>2. Sign In flow: email + password → loading spinner → dashboard</a:t>
             </a:r>
           </a:p>
           <a:p>
-            <a:pPr/>
-            <a:r>
-              <a:rPr/>
+            <a:r>
               <a:t>3. Dashboard: balance card (toggle visibility), quick actions grid, recent transactions, bottom nav switching</a:t>
             </a:r>
           </a:p>
           <a:p>
-            <a:pPr/>
-            <a:r>
-              <a:rPr/>
+            <a:r>
               <a:t>4. Buy Airtime flow: select network → confirm → payment method → success</a:t>
             </a:r>
           </a:p>
           <a:p>
-            <a:pPr/>
-            <a:r>
-              <a:rPr/>
+            <a:r>
               <a:t>5. Biometric login: fingerprint button → authenticate → bypass password</a:t>
             </a:r>
           </a:p>
           <a:p>
-            <a:pPr/>
-            <a:r>
-              <a:rPr/>
+            <a:r>
               <a:t>6. Logout → session cleared → redirected to landing</a:t>
             </a:r>
           </a:p>
@@ -4079,7 +4061,7 @@
 </file>
 
 <file path=ppt/slides/slide13.xml><?xml version="1.0" encoding="utf-8"?>
-<p:sld xmlns:a="http://schemas.openxmlformats.org/drawingml/2006/main" xmlns:p="http://schemas.openxmlformats.org/presentationml/2006/main" xmlns:r="http://schemas.openxmlformats.org/officeDocument/2006/relationships">
+<p:sld xmlns:a="http://schemas.openxmlformats.org/drawingml/2006/main" xmlns:r="http://schemas.openxmlformats.org/officeDocument/2006/relationships" xmlns:p="http://schemas.openxmlformats.org/presentationml/2006/main">
   <p:cSld>
     <p:spTree>
       <p:nvGrpSpPr>
@@ -4087,7 +4069,14 @@
         <p:cNvGrpSpPr/>
         <p:nvPr/>
       </p:nvGrpSpPr>
-      <p:grpSpPr/>
+      <p:grpSpPr>
+        <a:xfrm>
+          <a:off x="0" y="0"/>
+          <a:ext cx="0" cy="0"/>
+          <a:chOff x="0" y="0"/>
+          <a:chExt cx="0" cy="0"/>
+        </a:xfrm>
+      </p:grpSpPr>
       <p:sp>
         <p:nvSpPr>
           <p:cNvPr id="2" name="Title 1"/>
@@ -4124,30 +4113,22 @@
           <a:bodyPr/>
           <a:lstStyle/>
           <a:p>
-            <a:pPr/>
-            <a:r>
-              <a:rPr/>
+            <a:r>
               <a:t>Tatum Bank — Figma to Flutter conversion complete</a:t>
             </a:r>
           </a:p>
           <a:p>
-            <a:pPr/>
-            <a:r>
-              <a:rPr/>
+            <a:r>
               <a:t>26 screens · 6 modules · Clean architecture: UI / Data / Domain layers</a:t>
             </a:r>
           </a:p>
           <a:p>
-            <a:pPr/>
-            <a:r>
-              <a:rPr/>
+            <a:r>
               <a:t>Provider + ChangeNotifier for state · Http + SharedPreferences for data</a:t>
             </a:r>
           </a:p>
           <a:p>
-            <a:pPr/>
-            <a:r>
-              <a:rPr/>
+            <a:r>
               <a:t>Questions?</a:t>
             </a:r>
           </a:p>
@@ -4183,7 +4164,7 @@
 </file>
 
 <file path=ppt/slides/slide2.xml><?xml version="1.0" encoding="utf-8"?>
-<p:sld xmlns:a="http://schemas.openxmlformats.org/drawingml/2006/main" xmlns:p="http://schemas.openxmlformats.org/presentationml/2006/main" xmlns:r="http://schemas.openxmlformats.org/officeDocument/2006/relationships">
+<p:sld xmlns:a="http://schemas.openxmlformats.org/drawingml/2006/main" xmlns:r="http://schemas.openxmlformats.org/officeDocument/2006/relationships" xmlns:p="http://schemas.openxmlformats.org/presentationml/2006/main">
   <p:cSld>
     <p:spTree>
       <p:nvGrpSpPr>
@@ -4191,7 +4172,14 @@
         <p:cNvGrpSpPr/>
         <p:nvPr/>
       </p:nvGrpSpPr>
-      <p:grpSpPr/>
+      <p:grpSpPr>
+        <a:xfrm>
+          <a:off x="0" y="0"/>
+          <a:ext cx="0" cy="0"/>
+          <a:chOff x="0" y="0"/>
+          <a:chExt cx="0" cy="0"/>
+        </a:xfrm>
+      </p:grpSpPr>
       <p:sp>
         <p:nvSpPr>
           <p:cNvPr id="2" name="Title 1"/>
@@ -4228,44 +4216,32 @@
           <a:bodyPr/>
           <a:lstStyle/>
           <a:p>
-            <a:pPr/>
-            <a:r>
-              <a:rPr/>
+            <a:r>
               <a:t>Translating a detailed Figma mobile design into production-ready Flutter &amp; Dart code</a:t>
             </a:r>
           </a:p>
           <a:p>
-            <a:pPr/>
-            <a:r>
-              <a:rPr/>
+            <a:r>
               <a:t>26 screens across 6 feature modules to implement</a:t>
             </a:r>
           </a:p>
           <a:p>
-            <a:pPr/>
-            <a:r>
-              <a:rPr/>
+            <a:r>
               <a:t>Matching pixel-perfect Figma layouts with Flutter widgets</a:t>
             </a:r>
           </a:p>
           <a:p>
-            <a:pPr/>
-            <a:r>
-              <a:rPr/>
+            <a:r>
               <a:t>Integrating with a live REST API (Tatum Connect Backend)</a:t>
             </a:r>
           </a:p>
           <a:p>
-            <a:pPr/>
-            <a:r>
-              <a:rPr/>
+            <a:r>
               <a:t>Managing authentication state across login, OTP, registration, and biometric flows</a:t>
             </a:r>
           </a:p>
           <a:p>
-            <a:pPr/>
-            <a:r>
-              <a:rPr/>
+            <a:r>
               <a:t>Delivering a consistent brand experience: yellow (#FFC727) + navy (#0B192C) design system</a:t>
             </a:r>
           </a:p>
@@ -4301,7 +4277,7 @@
 </file>
 
 <file path=ppt/slides/slide3.xml><?xml version="1.0" encoding="utf-8"?>
-<p:sld xmlns:a="http://schemas.openxmlformats.org/drawingml/2006/main" xmlns:p="http://schemas.openxmlformats.org/presentationml/2006/main" xmlns:r="http://schemas.openxmlformats.org/officeDocument/2006/relationships">
+<p:sld xmlns:a="http://schemas.openxmlformats.org/drawingml/2006/main" xmlns:r="http://schemas.openxmlformats.org/officeDocument/2006/relationships" xmlns:p="http://schemas.openxmlformats.org/presentationml/2006/main">
   <p:cSld>
     <p:spTree>
       <p:nvGrpSpPr>
@@ -4309,7 +4285,14 @@
         <p:cNvGrpSpPr/>
         <p:nvPr/>
       </p:nvGrpSpPr>
-      <p:grpSpPr/>
+      <p:grpSpPr>
+        <a:xfrm>
+          <a:off x="0" y="0"/>
+          <a:ext cx="0" cy="0"/>
+          <a:chOff x="0" y="0"/>
+          <a:chExt cx="0" cy="0"/>
+        </a:xfrm>
+      </p:grpSpPr>
       <p:sp>
         <p:nvSpPr>
           <p:cNvPr id="2" name="Title 1"/>
@@ -4346,86 +4329,68 @@
           <a:bodyPr/>
           <a:lstStyle/>
           <a:p>
-            <a:pPr/>
             <a:r>
               <a:rPr b="1"/>
               <a:t>Module 1 — Authentication &amp; User Access (10 screens)</a:t>
             </a:r>
           </a:p>
           <a:p>
-            <a:pPr/>
-            <a:r>
-              <a:rPr/>
+            <a:r>
               <a:t>Landing / Get Started → Sign In → Register → Phone OTP → Email OTP → Biometric Setup → Permissions → Welcome → Security Setup → Account Created</a:t>
             </a:r>
           </a:p>
           <a:p>
-            <a:pPr/>
             <a:r>
               <a:rPr b="1"/>
               <a:t>Module 2 — Operations Dashboard (3 screens)</a:t>
             </a:r>
           </a:p>
           <a:p>
-            <a:pPr/>
-            <a:r>
-              <a:rPr/>
+            <a:r>
               <a:t>Home Dashboard → Account Detail → Spending Analytics</a:t>
             </a:r>
           </a:p>
           <a:p>
-            <a:pPr/>
             <a:r>
               <a:rPr b="1"/>
               <a:t>Module 3 — Transactions / Buy Airtime (4 screens)</a:t>
             </a:r>
           </a:p>
           <a:p>
-            <a:pPr/>
-            <a:r>
-              <a:rPr/>
+            <a:r>
               <a:t>Airtime Selection → Confirmation → Payment Method → Success</a:t>
             </a:r>
           </a:p>
           <a:p>
-            <a:pPr/>
             <a:r>
               <a:rPr b="1"/>
               <a:t>Module 3a — Transaction History (3 screens)</a:t>
             </a:r>
           </a:p>
           <a:p>
-            <a:pPr/>
-            <a:r>
-              <a:rPr/>
+            <a:r>
               <a:t>Full History → Transaction Detail → Filtered View</a:t>
             </a:r>
           </a:p>
           <a:p>
-            <a:pPr/>
             <a:r>
               <a:rPr b="1"/>
               <a:t>Module 4 — Customer Service (2 screens)</a:t>
             </a:r>
           </a:p>
           <a:p>
-            <a:pPr/>
-            <a:r>
-              <a:rPr/>
+            <a:r>
               <a:t>Support Home → Live Chat</a:t>
             </a:r>
           </a:p>
           <a:p>
-            <a:pPr/>
             <a:r>
               <a:rPr b="1"/>
               <a:t>Module 5 — Notifications &amp; Profile (4 screens)</a:t>
             </a:r>
           </a:p>
           <a:p>
-            <a:pPr/>
-            <a:r>
-              <a:rPr/>
+            <a:r>
               <a:t>Notifications List → Notification Detail → Profile → Settings</a:t>
             </a:r>
           </a:p>
@@ -4440,7 +4405,7 @@
 </file>
 
 <file path=ppt/slides/slide4.xml><?xml version="1.0" encoding="utf-8"?>
-<p:sld xmlns:a="http://schemas.openxmlformats.org/drawingml/2006/main" xmlns:p="http://schemas.openxmlformats.org/presentationml/2006/main" xmlns:r="http://schemas.openxmlformats.org/officeDocument/2006/relationships">
+<p:sld xmlns:a="http://schemas.openxmlformats.org/drawingml/2006/main" xmlns:r="http://schemas.openxmlformats.org/officeDocument/2006/relationships" xmlns:p="http://schemas.openxmlformats.org/presentationml/2006/main">
   <p:cSld>
     <p:spTree>
       <p:nvGrpSpPr>
@@ -4448,7 +4413,14 @@
         <p:cNvGrpSpPr/>
         <p:nvPr/>
       </p:nvGrpSpPr>
-      <p:grpSpPr/>
+      <p:grpSpPr>
+        <a:xfrm>
+          <a:off x="0" y="0"/>
+          <a:ext cx="0" cy="0"/>
+          <a:chOff x="0" y="0"/>
+          <a:chExt cx="0" cy="0"/>
+        </a:xfrm>
+      </p:grpSpPr>
       <p:pic>
         <p:nvPicPr>
           <p:cNvPr id="2" name="Picture 1" descr="image_902fb9.png"/>
@@ -4458,15 +4430,15 @@
           <p:nvPr/>
         </p:nvPicPr>
         <p:blipFill>
-          <a:blip r:embed="rId2"/>
+          <a:blip r:embed="rId3"/>
           <a:stretch>
             <a:fillRect/>
           </a:stretch>
         </p:blipFill>
         <p:spPr>
           <a:xfrm>
-            <a:off x="457200" y="457200"/>
-            <a:ext cx="11247120" cy="24743664"/>
+            <a:off x="3557391" y="512255"/>
+            <a:ext cx="5285983" cy="5656814"/>
           </a:xfrm>
           <a:prstGeom prst="rect">
             <a:avLst/>
@@ -4482,7 +4454,7 @@
 </file>
 
 <file path=ppt/slides/slide5.xml><?xml version="1.0" encoding="utf-8"?>
-<p:sld xmlns:a="http://schemas.openxmlformats.org/drawingml/2006/main" xmlns:p="http://schemas.openxmlformats.org/presentationml/2006/main" xmlns:r="http://schemas.openxmlformats.org/officeDocument/2006/relationships">
+<p:sld xmlns:a="http://schemas.openxmlformats.org/drawingml/2006/main" xmlns:r="http://schemas.openxmlformats.org/officeDocument/2006/relationships" xmlns:p="http://schemas.openxmlformats.org/presentationml/2006/main">
   <p:cSld>
     <p:spTree>
       <p:nvGrpSpPr>
@@ -4490,7 +4462,14 @@
         <p:cNvGrpSpPr/>
         <p:nvPr/>
       </p:nvGrpSpPr>
-      <p:grpSpPr/>
+      <p:grpSpPr>
+        <a:xfrm>
+          <a:off x="0" y="0"/>
+          <a:ext cx="0" cy="0"/>
+          <a:chOff x="0" y="0"/>
+          <a:chExt cx="0" cy="0"/>
+        </a:xfrm>
+      </p:grpSpPr>
       <p:sp>
         <p:nvSpPr>
           <p:cNvPr id="2" name="Title 1"/>
@@ -4527,7 +4506,6 @@
           <a:bodyPr/>
           <a:lstStyle/>
           <a:p>
-            <a:pPr/>
             <a:r>
               <a:rPr b="1">
                 <a:solidFill>
@@ -4538,42 +4516,31 @@
             </a:r>
           </a:p>
           <a:p>
-            <a:pPr/>
-            <a:r>
-              <a:rPr/>
+            <a:r>
               <a:t>Flutter widgets: Scaffold, SafeArea, SingleChildScrollView, Column, Row, Container,GestureDetector</a:t>
             </a:r>
           </a:p>
           <a:p>
-            <a:pPr/>
-            <a:r>
-              <a:rPr/>
+            <a:r>
               <a:t>Custom paint: TatumLogoWidget with _TatumIconPainter (4-tile logo)</a:t>
             </a:r>
           </a:p>
           <a:p>
-            <a:pPr/>
-            <a:r>
-              <a:rPr/>
+            <a:r>
               <a:t>Reusable tiles: _QuickActionTile, _TransactionTile — stateless widgets</a:t>
             </a:r>
           </a:p>
           <a:p>
-            <a:pPr/>
-            <a:r>
-              <a:rPr/>
+            <a:r>
               <a:t>BottomNavigationBar with 5 tabs, custom icon containers with active-state yellow highlight</a:t>
             </a:r>
           </a:p>
           <a:p>
-            <a:pPr/>
-            <a:r>
-              <a:rPr/>
+            <a:r>
               <a:t>Responsive Flex layouts: Expanded, Flexible, ConstrainedBox for varied screen sizes</a:t>
             </a:r>
           </a:p>
           <a:p>
-            <a:pPr/>
             <a:r>
               <a:rPr b="1">
                 <a:solidFill>
@@ -4584,35 +4551,26 @@
             </a:r>
           </a:p>
           <a:p>
-            <a:pPr/>
-            <a:r>
-              <a:rPr/>
+            <a:r>
               <a:t>HttpAuthRepository implements AuthRepository interface — clean separation of contract vs implementation</a:t>
             </a:r>
           </a:p>
           <a:p>
-            <a:pPr/>
-            <a:r>
-              <a:rPr/>
+            <a:r>
               <a:t>APIRoute class: centralized endpoint strings (baseUrl, Auth/*, Notifications/*, Products/*, Transactions/*)</a:t>
             </a:r>
           </a:p>
           <a:p>
-            <a:pPr/>
-            <a:r>
-              <a:rPr/>
+            <a:r>
               <a:t>ResponseHandler: maps HTTP responses → domain models, throws typed exceptions</a:t>
             </a:r>
           </a:p>
           <a:p>
-            <a:pPr/>
-            <a:r>
-              <a:rPr/>
+            <a:r>
               <a:t>SharedPreferences: persists auth_token locally for session restore</a:t>
             </a:r>
           </a:p>
           <a:p>
-            <a:pPr/>
             <a:r>
               <a:rPr b="1">
                 <a:solidFill>
@@ -4623,30 +4581,22 @@
             </a:r>
           </a:p>
           <a:p>
-            <a:pPr/>
-            <a:r>
-              <a:rPr/>
+            <a:r>
               <a:t>AuthProvider extends ChangeNotifier — single source of truth for user session</a:t>
             </a:r>
           </a:p>
           <a:p>
-            <a:pPr/>
-            <a:r>
-              <a:rPr/>
+            <a:r>
               <a:t>ViewState enum: idle / loading / success / empty / error — drives UI reaction</a:t>
             </a:r>
           </a:p>
           <a:p>
-            <a:pPr/>
-            <a:r>
-              <a:rPr/>
+            <a:r>
               <a:t>MultiProvider at app root wraps MyApp; Consumer&lt;AuthProvider&gt; drives home route</a:t>
             </a:r>
           </a:p>
           <a:p>
-            <a:pPr/>
-            <a:r>
-              <a:rPr/>
+            <a:r>
               <a:t>Field-level validation errors mapped from ValidationException into TextField errorText</a:t>
             </a:r>
           </a:p>
@@ -4661,7 +4611,7 @@
 </file>
 
 <file path=ppt/slides/slide6.xml><?xml version="1.0" encoding="utf-8"?>
-<p:sld xmlns:a="http://schemas.openxmlformats.org/drawingml/2006/main" xmlns:p="http://schemas.openxmlformats.org/presentationml/2006/main" xmlns:r="http://schemas.openxmlformats.org/officeDocument/2006/relationships">
+<p:sld xmlns:a="http://schemas.openxmlformats.org/drawingml/2006/main" xmlns:r="http://schemas.openxmlformats.org/officeDocument/2006/relationships" xmlns:p="http://schemas.openxmlformats.org/presentationml/2006/main">
   <p:cSld>
     <p:spTree>
       <p:nvGrpSpPr>
@@ -4669,7 +4619,14 @@
         <p:cNvGrpSpPr/>
         <p:nvPr/>
       </p:nvGrpSpPr>
-      <p:grpSpPr/>
+      <p:grpSpPr>
+        <a:xfrm>
+          <a:off x="0" y="0"/>
+          <a:ext cx="0" cy="0"/>
+          <a:chOff x="0" y="0"/>
+          <a:chExt cx="0" cy="0"/>
+        </a:xfrm>
+      </p:grpSpPr>
       <p:sp>
         <p:nvSpPr>
           <p:cNvPr id="2" name="Title 1"/>
@@ -4698,31 +4655,25 @@
             <a:spLocks noGrp="1"/>
           </p:cNvSpPr>
           <p:nvPr>
-            <p:ph idx="1" sz="half"/>
-          </p:nvPr>
-        </p:nvSpPr>
-        <p:spPr/>
-        <p:txBody>
-          <a:bodyPr/>
-          <a:lstStyle/>
-          <a:p>
-            <a:pPr/>
-            <a:r>
-              <a:rPr/>
+            <p:ph sz="half" idx="1"/>
+          </p:nvPr>
+        </p:nvSpPr>
+        <p:spPr/>
+        <p:txBody>
+          <a:bodyPr/>
+          <a:lstStyle/>
+          <a:p>
+            <a:r>
               <a:t>DashboardScreen: main hub with balance card, quick actions, recent transactions, bottom nav</a:t>
             </a:r>
           </a:p>
           <a:p>
-            <a:pPr/>
-            <a:r>
-              <a:rPr/>
+            <a:r>
               <a:t>_QuickActionTile: stateless widget — icon + label, tap handler</a:t>
             </a:r>
           </a:p>
           <a:p>
-            <a:pPr/>
-            <a:r>
-              <a:rPr/>
+            <a:r>
               <a:t>_TransactionTile: InkWell row with icon circle, title, date, amount, status</a:t>
             </a:r>
           </a:p>
@@ -4735,14 +4686,16 @@
             <a:spLocks noGrp="1"/>
           </p:cNvSpPr>
           <p:nvPr>
-            <p:ph idx="2" sz="half"/>
-          </p:nvPr>
-        </p:nvSpPr>
-        <p:spPr/>
-        <p:txBody>
-          <a:bodyPr/>
-          <a:lstStyle/>
-          <a:p/>
+            <p:ph sz="half" idx="2"/>
+          </p:nvPr>
+        </p:nvSpPr>
+        <p:spPr/>
+        <p:txBody>
+          <a:bodyPr/>
+          <a:lstStyle/>
+          <a:p>
+            <a:endParaRPr/>
+          </a:p>
         </p:txBody>
       </p:sp>
     </p:spTree>
@@ -4754,7 +4707,7 @@
 </file>
 
 <file path=ppt/slides/slide7.xml><?xml version="1.0" encoding="utf-8"?>
-<p:sld xmlns:a="http://schemas.openxmlformats.org/drawingml/2006/main" xmlns:p="http://schemas.openxmlformats.org/presentationml/2006/main" xmlns:r="http://schemas.openxmlformats.org/officeDocument/2006/relationships">
+<p:sld xmlns:a="http://schemas.openxmlformats.org/drawingml/2006/main" xmlns:r="http://schemas.openxmlformats.org/officeDocument/2006/relationships" xmlns:p="http://schemas.openxmlformats.org/presentationml/2006/main">
   <p:cSld>
     <p:spTree>
       <p:nvGrpSpPr>
@@ -4762,7 +4715,14 @@
         <p:cNvGrpSpPr/>
         <p:nvPr/>
       </p:nvGrpSpPr>
-      <p:grpSpPr/>
+      <p:grpSpPr>
+        <a:xfrm>
+          <a:off x="0" y="0"/>
+          <a:ext cx="0" cy="0"/>
+          <a:chOff x="0" y="0"/>
+          <a:chExt cx="0" cy="0"/>
+        </a:xfrm>
+      </p:grpSpPr>
       <p:sp>
         <p:nvSpPr>
           <p:cNvPr id="2" name="Title 1"/>
@@ -4791,31 +4751,25 @@
             <a:spLocks noGrp="1"/>
           </p:cNvSpPr>
           <p:nvPr>
-            <p:ph idx="1" sz="half"/>
-          </p:nvPr>
-        </p:nvSpPr>
-        <p:spPr/>
-        <p:txBody>
-          <a:bodyPr/>
-          <a:lstStyle/>
-          <a:p>
-            <a:pPr/>
-            <a:r>
-              <a:rPr/>
+            <p:ph sz="half" idx="1"/>
+          </p:nvPr>
+        </p:nvSpPr>
+        <p:spPr/>
+        <p:txBody>
+          <a:bodyPr/>
+          <a:lstStyle/>
+          <a:p>
+            <a:r>
               <a:t>APIRoute: all endpoints in one file — Auth, Notifications, Products, Transactions, Users</a:t>
             </a:r>
           </a:p>
           <a:p>
-            <a:pPr/>
-            <a:r>
-              <a:rPr/>
+            <a:r>
               <a:t>HttpAuthRepository: POST/GET with Bearer token, persists token via SharedPreferences</a:t>
             </a:r>
           </a:p>
           <a:p>
-            <a:pPr/>
-            <a:r>
-              <a:rPr/>
+            <a:r>
               <a:t>restoreSession(): reads token from prefs, calls /Auth/me, returns User or null</a:t>
             </a:r>
           </a:p>
@@ -4828,14 +4782,16 @@
             <a:spLocks noGrp="1"/>
           </p:cNvSpPr>
           <p:nvPr>
-            <p:ph idx="2" sz="half"/>
-          </p:nvPr>
-        </p:nvSpPr>
-        <p:spPr/>
-        <p:txBody>
-          <a:bodyPr/>
-          <a:lstStyle/>
-          <a:p/>
+            <p:ph sz="half" idx="2"/>
+          </p:nvPr>
+        </p:nvSpPr>
+        <p:spPr/>
+        <p:txBody>
+          <a:bodyPr/>
+          <a:lstStyle/>
+          <a:p>
+            <a:endParaRPr/>
+          </a:p>
         </p:txBody>
       </p:sp>
     </p:spTree>
@@ -4847,7 +4803,7 @@
 </file>
 
 <file path=ppt/slides/slide8.xml><?xml version="1.0" encoding="utf-8"?>
-<p:sld xmlns:a="http://schemas.openxmlformats.org/drawingml/2006/main" xmlns:p="http://schemas.openxmlformats.org/presentationml/2006/main" xmlns:r="http://schemas.openxmlformats.org/officeDocument/2006/relationships">
+<p:sld xmlns:a="http://schemas.openxmlformats.org/drawingml/2006/main" xmlns:r="http://schemas.openxmlformats.org/officeDocument/2006/relationships" xmlns:p="http://schemas.openxmlformats.org/presentationml/2006/main">
   <p:cSld>
     <p:spTree>
       <p:nvGrpSpPr>
@@ -4855,7 +4811,14 @@
         <p:cNvGrpSpPr/>
         <p:nvPr/>
       </p:nvGrpSpPr>
-      <p:grpSpPr/>
+      <p:grpSpPr>
+        <a:xfrm>
+          <a:off x="0" y="0"/>
+          <a:ext cx="0" cy="0"/>
+          <a:chOff x="0" y="0"/>
+          <a:chExt cx="0" cy="0"/>
+        </a:xfrm>
+      </p:grpSpPr>
       <p:sp>
         <p:nvSpPr>
           <p:cNvPr id="2" name="Title 1"/>
@@ -4884,38 +4847,30 @@
             <a:spLocks noGrp="1"/>
           </p:cNvSpPr>
           <p:nvPr>
-            <p:ph idx="1" sz="half"/>
-          </p:nvPr>
-        </p:nvSpPr>
-        <p:spPr/>
-        <p:txBody>
-          <a:bodyPr/>
-          <a:lstStyle/>
-          <a:p>
-            <a:pPr/>
-            <a:r>
-              <a:rPr/>
+            <p:ph sz="half" idx="1"/>
+          </p:nvPr>
+        </p:nvSpPr>
+        <p:spPr/>
+        <p:txBody>
+          <a:bodyPr/>
+          <a:lstStyle/>
+          <a:p>
+            <a:r>
               <a:t>AuthProvider: ChangeNotifier with _user, loginState, registerState, errorMessage, fieldErrors</a:t>
             </a:r>
           </a:p>
           <a:p>
-            <a:pPr/>
-            <a:r>
-              <a:rPr/>
+            <a:r>
               <a:t>login(email, password) → _repo.login() → ViewState.loading → success/error → notifyListeners()</a:t>
             </a:r>
           </a:p>
           <a:p>
-            <a:pPr/>
-            <a:r>
-              <a:rPr/>
+            <a:r>
               <a:t>bootstrap(): called at app start — attempts session restore from stored token</a:t>
             </a:r>
           </a:p>
           <a:p>
-            <a:pPr/>
-            <a:r>
-              <a:rPr/>
+            <a:r>
               <a:t>logout(): clears _user, resets state, calls _repo.logout(token)</a:t>
             </a:r>
           </a:p>
@@ -4928,14 +4883,16 @@
             <a:spLocks noGrp="1"/>
           </p:cNvSpPr>
           <p:nvPr>
-            <p:ph idx="2" sz="half"/>
-          </p:nvPr>
-        </p:nvSpPr>
-        <p:spPr/>
-        <p:txBody>
-          <a:bodyPr/>
-          <a:lstStyle/>
-          <a:p/>
+            <p:ph sz="half" idx="2"/>
+          </p:nvPr>
+        </p:nvSpPr>
+        <p:spPr/>
+        <p:txBody>
+          <a:bodyPr/>
+          <a:lstStyle/>
+          <a:p>
+            <a:endParaRPr/>
+          </a:p>
         </p:txBody>
       </p:sp>
     </p:spTree>
@@ -4947,7 +4904,7 @@
 </file>
 
 <file path=ppt/slides/slide9.xml><?xml version="1.0" encoding="utf-8"?>
-<p:sld xmlns:a="http://schemas.openxmlformats.org/drawingml/2006/main" xmlns:p="http://schemas.openxmlformats.org/presentationml/2006/main" xmlns:r="http://schemas.openxmlformats.org/officeDocument/2006/relationships">
+<p:sld xmlns:a="http://schemas.openxmlformats.org/drawingml/2006/main" xmlns:r="http://schemas.openxmlformats.org/officeDocument/2006/relationships" xmlns:p="http://schemas.openxmlformats.org/presentationml/2006/main">
   <p:cSld>
     <p:spTree>
       <p:nvGrpSpPr>
@@ -4955,7 +4912,14 @@
         <p:cNvGrpSpPr/>
         <p:nvPr/>
       </p:nvGrpSpPr>
-      <p:grpSpPr/>
+      <p:grpSpPr>
+        <a:xfrm>
+          <a:off x="0" y="0"/>
+          <a:ext cx="0" cy="0"/>
+          <a:chOff x="0" y="0"/>
+          <a:chExt cx="0" cy="0"/>
+        </a:xfrm>
+      </p:grpSpPr>
       <p:sp>
         <p:nvSpPr>
           <p:cNvPr id="2" name="Title 1"/>
@@ -4992,7 +4956,6 @@
           <a:bodyPr/>
           <a:lstStyle/>
           <a:p>
-            <a:pPr/>
             <a:r>
               <a:rPr b="1">
                 <a:solidFill>
@@ -5003,21 +4966,16 @@
             </a:r>
           </a:p>
           <a:p>
-            <a:pPr/>
-            <a:r>
-              <a:rPr/>
+            <a:r>
               <a:t>Figma uses auto-layout with flexbox-like behavior; Flutter uses Row/Column/Expanded/Flexible</a:t>
             </a:r>
           </a:p>
           <a:p>
-            <a:pPr/>
-            <a:r>
-              <a:rPr/>
+            <a:r>
               <a:t>Fix: Replaced Figma spacer frames with SizedBox(height: X) and Spacer() widgets; used Expanded/Flexible for proportional sizing</a:t>
             </a:r>
           </a:p>
           <a:p>
-            <a:pPr/>
             <a:r>
               <a:rPr b="1">
                 <a:solidFill>
@@ -5028,21 +4986,16 @@
             </a:r>
           </a:p>
           <a:p>
-            <a:pPr/>
-            <a:r>
-              <a:rPr/>
+            <a:r>
               <a:t>Risk of copy-pasting hex values and drifting from the design system</a:t>
             </a:r>
           </a:p>
           <a:p>
-            <a:pPr/>
-            <a:r>
-              <a:rPr/>
+            <a:r>
               <a:t>Fix: Centralized in AppColors class (app_colors.dart) — primary=#FFC727, navy=#0B192C; AppTheme provides ThemeData with ColorScheme</a:t>
             </a:r>
           </a:p>
           <a:p>
-            <a:pPr/>
             <a:r>
               <a:rPr b="1">
                 <a:solidFill>
@@ -5053,16 +5006,12 @@
             </a:r>
           </a:p>
           <a:p>
-            <a:pPr/>
-            <a:r>
-              <a:rPr/>
+            <a:r>
               <a:t>Default BottomNavigationBar doesn't support container backgrounds per item</a:t>
             </a:r>
           </a:p>
           <a:p>
-            <a:pPr/>
-            <a:r>
-              <a:rPr/>
+            <a:r>
               <a:t>Fix: Built custom icon Container with BoxDecoration(color: index==selected ? yellow : transparent) — dashboard_screen.dart lines 620-628</a:t>
             </a:r>
           </a:p>
@@ -5407,44 +5356,44 @@
         <a:sysClr val="window" lastClr="FFFFFF"/>
       </a:lt1>
       <a:dk2>
-        <a:srgbClr val="1F497D"/>
+        <a:srgbClr val="44546A"/>
       </a:dk2>
       <a:lt2>
-        <a:srgbClr val="EEECE1"/>
+        <a:srgbClr val="E7E6E6"/>
       </a:lt2>
       <a:accent1>
-        <a:srgbClr val="4F81BD"/>
+        <a:srgbClr val="4472C4"/>
       </a:accent1>
       <a:accent2>
-        <a:srgbClr val="C0504D"/>
+        <a:srgbClr val="ED7D31"/>
       </a:accent2>
       <a:accent3>
-        <a:srgbClr val="9BBB59"/>
+        <a:srgbClr val="A5A5A5"/>
       </a:accent3>
       <a:accent4>
-        <a:srgbClr val="8064A2"/>
+        <a:srgbClr val="FFC000"/>
       </a:accent4>
       <a:accent5>
-        <a:srgbClr val="4BACC6"/>
+        <a:srgbClr val="5B9BD5"/>
       </a:accent5>
       <a:accent6>
-        <a:srgbClr val="F79646"/>
+        <a:srgbClr val="70AD47"/>
       </a:accent6>
       <a:hlink>
-        <a:srgbClr val="0000FF"/>
+        <a:srgbClr val="0563C1"/>
       </a:hlink>
       <a:folHlink>
-        <a:srgbClr val="800080"/>
+        <a:srgbClr val="954F72"/>
       </a:folHlink>
     </a:clrScheme>
     <a:fontScheme name="Office">
       <a:majorFont>
-        <a:latin typeface="Calibri"/>
+        <a:latin typeface="Calibri Light" panose="020F0302020204030204"/>
         <a:ea typeface=""/>
         <a:cs typeface=""/>
-        <a:font script="Jpan" typeface="ＭＳ Ｐゴシック"/>
+        <a:font script="Jpan" typeface="游ゴシック Light"/>
         <a:font script="Hang" typeface="맑은 고딕"/>
-        <a:font script="Hans" typeface="宋体"/>
+        <a:font script="Hans" typeface="等线 Light"/>
         <a:font script="Hant" typeface="新細明體"/>
         <a:font script="Arab" typeface="Times New Roman"/>
         <a:font script="Hebr" typeface="Times New Roman"/>
@@ -5472,14 +5421,31 @@
         <a:font script="Viet" typeface="Times New Roman"/>
         <a:font script="Uigh" typeface="Microsoft Uighur"/>
         <a:font script="Geor" typeface="Sylfaen"/>
+        <a:font script="Armn" typeface="Arial"/>
+        <a:font script="Bugi" typeface="Leelawadee UI"/>
+        <a:font script="Bopo" typeface="Microsoft JhengHei"/>
+        <a:font script="Java" typeface="Javanese Text"/>
+        <a:font script="Lisu" typeface="Segoe UI"/>
+        <a:font script="Mymr" typeface="Myanmar Text"/>
+        <a:font script="Nkoo" typeface="Ebrima"/>
+        <a:font script="Olck" typeface="Nirmala UI"/>
+        <a:font script="Osma" typeface="Ebrima"/>
+        <a:font script="Phag" typeface="Phagspa"/>
+        <a:font script="Syrn" typeface="Estrangelo Edessa"/>
+        <a:font script="Syrj" typeface="Estrangelo Edessa"/>
+        <a:font script="Syre" typeface="Estrangelo Edessa"/>
+        <a:font script="Sora" typeface="Nirmala UI"/>
+        <a:font script="Tale" typeface="Microsoft Tai Le"/>
+        <a:font script="Talu" typeface="Microsoft New Tai Lue"/>
+        <a:font script="Tfng" typeface="Ebrima"/>
       </a:majorFont>
       <a:minorFont>
-        <a:latin typeface="Calibri"/>
+        <a:latin typeface="Calibri" panose="020F0502020204030204"/>
         <a:ea typeface=""/>
         <a:cs typeface=""/>
-        <a:font script="Jpan" typeface="ＭＳ Ｐゴシック"/>
+        <a:font script="Jpan" typeface="游ゴシック"/>
         <a:font script="Hang" typeface="맑은 고딕"/>
-        <a:font script="Hans" typeface="宋体"/>
+        <a:font script="Hans" typeface="等线"/>
         <a:font script="Hant" typeface="新細明體"/>
         <a:font script="Arab" typeface="Arial"/>
         <a:font script="Hebr" typeface="Arial"/>
@@ -5507,6 +5473,23 @@
         <a:font script="Viet" typeface="Arial"/>
         <a:font script="Uigh" typeface="Microsoft Uighur"/>
         <a:font script="Geor" typeface="Sylfaen"/>
+        <a:font script="Armn" typeface="Arial"/>
+        <a:font script="Bugi" typeface="Leelawadee UI"/>
+        <a:font script="Bopo" typeface="Microsoft JhengHei"/>
+        <a:font script="Java" typeface="Javanese Text"/>
+        <a:font script="Lisu" typeface="Segoe UI"/>
+        <a:font script="Mymr" typeface="Myanmar Text"/>
+        <a:font script="Nkoo" typeface="Ebrima"/>
+        <a:font script="Olck" typeface="Nirmala UI"/>
+        <a:font script="Osma" typeface="Ebrima"/>
+        <a:font script="Phag" typeface="Phagspa"/>
+        <a:font script="Syrn" typeface="Estrangelo Edessa"/>
+        <a:font script="Syrj" typeface="Estrangelo Edessa"/>
+        <a:font script="Syre" typeface="Estrangelo Edessa"/>
+        <a:font script="Sora" typeface="Nirmala UI"/>
+        <a:font script="Tale" typeface="Microsoft Tai Le"/>
+        <a:font script="Talu" typeface="Microsoft New Tai Lue"/>
+        <a:font script="Tfng" typeface="Ebrima"/>
       </a:minorFont>
     </a:fontScheme>
     <a:fmtScheme name="Office">
@@ -5518,200 +5501,141 @@
           <a:gsLst>
             <a:gs pos="0">
               <a:schemeClr val="phClr">
-                <a:tint val="50000"/>
-                <a:satMod val="300000"/>
+                <a:lumMod val="110000"/>
+                <a:satMod val="105000"/>
+                <a:tint val="67000"/>
               </a:schemeClr>
             </a:gs>
-            <a:gs pos="35000">
+            <a:gs pos="50000">
               <a:schemeClr val="phClr">
-                <a:tint val="37000"/>
-                <a:satMod val="300000"/>
+                <a:lumMod val="105000"/>
+                <a:satMod val="103000"/>
+                <a:tint val="73000"/>
               </a:schemeClr>
             </a:gs>
             <a:gs pos="100000">
               <a:schemeClr val="phClr">
-                <a:tint val="15000"/>
-                <a:satMod val="350000"/>
+                <a:lumMod val="105000"/>
+                <a:satMod val="109000"/>
+                <a:tint val="81000"/>
               </a:schemeClr>
             </a:gs>
           </a:gsLst>
-          <a:lin ang="16200000" scaled="1"/>
+          <a:lin ang="5400000" scaled="0"/>
         </a:gradFill>
         <a:gradFill rotWithShape="1">
           <a:gsLst>
             <a:gs pos="0">
               <a:schemeClr val="phClr">
-                <a:tint val="100000"/>
+                <a:satMod val="103000"/>
+                <a:lumMod val="102000"/>
+                <a:tint val="94000"/>
+              </a:schemeClr>
+            </a:gs>
+            <a:gs pos="50000">
+              <a:schemeClr val="phClr">
+                <a:satMod val="110000"/>
+                <a:lumMod val="100000"/>
                 <a:shade val="100000"/>
-                <a:satMod val="130000"/>
               </a:schemeClr>
             </a:gs>
             <a:gs pos="100000">
               <a:schemeClr val="phClr">
-                <a:tint val="50000"/>
-                <a:shade val="100000"/>
-                <a:satMod val="350000"/>
+                <a:lumMod val="99000"/>
+                <a:satMod val="120000"/>
+                <a:shade val="78000"/>
               </a:schemeClr>
             </a:gs>
           </a:gsLst>
-          <a:lin ang="16200000" scaled="0"/>
+          <a:lin ang="5400000" scaled="0"/>
         </a:gradFill>
       </a:fillStyleLst>
       <a:lnStyleLst>
-        <a:ln w="9525" cap="flat" cmpd="sng" algn="ctr">
-          <a:solidFill>
-            <a:schemeClr val="phClr">
-              <a:shade val="95000"/>
-              <a:satMod val="105000"/>
-            </a:schemeClr>
-          </a:solidFill>
-          <a:prstDash val="solid"/>
-        </a:ln>
-        <a:ln w="25400" cap="flat" cmpd="sng" algn="ctr">
+        <a:ln w="6350" cap="flat" cmpd="sng" algn="ctr">
           <a:solidFill>
             <a:schemeClr val="phClr"/>
           </a:solidFill>
           <a:prstDash val="solid"/>
+          <a:miter lim="800000"/>
         </a:ln>
-        <a:ln w="38100" cap="flat" cmpd="sng" algn="ctr">
+        <a:ln w="12700" cap="flat" cmpd="sng" algn="ctr">
           <a:solidFill>
             <a:schemeClr val="phClr"/>
           </a:solidFill>
           <a:prstDash val="solid"/>
+          <a:miter lim="800000"/>
+        </a:ln>
+        <a:ln w="19050" cap="flat" cmpd="sng" algn="ctr">
+          <a:solidFill>
+            <a:schemeClr val="phClr"/>
+          </a:solidFill>
+          <a:prstDash val="solid"/>
+          <a:miter lim="800000"/>
         </a:ln>
       </a:lnStyleLst>
       <a:effectStyleLst>
         <a:effectStyle>
+          <a:effectLst/>
+        </a:effectStyle>
+        <a:effectStyle>
+          <a:effectLst/>
+        </a:effectStyle>
+        <a:effectStyle>
           <a:effectLst>
-            <a:outerShdw blurRad="40000" dist="20000" dir="5400000" rotWithShape="0">
+            <a:outerShdw blurRad="57150" dist="19050" dir="5400000" algn="ctr" rotWithShape="0">
               <a:srgbClr val="000000">
-                <a:alpha val="38000"/>
+                <a:alpha val="63000"/>
               </a:srgbClr>
             </a:outerShdw>
           </a:effectLst>
-        </a:effectStyle>
-        <a:effectStyle>
-          <a:effectLst>
-            <a:outerShdw blurRad="40000" dist="23000" dir="5400000" rotWithShape="0">
-              <a:srgbClr val="000000">
-                <a:alpha val="35000"/>
-              </a:srgbClr>
-            </a:outerShdw>
-          </a:effectLst>
-        </a:effectStyle>
-        <a:effectStyle>
-          <a:effectLst>
-            <a:outerShdw blurRad="40000" dist="23000" dir="5400000" rotWithShape="0">
-              <a:srgbClr val="000000">
-                <a:alpha val="35000"/>
-              </a:srgbClr>
-            </a:outerShdw>
-          </a:effectLst>
-          <a:scene3d>
-            <a:camera prst="orthographicFront">
-              <a:rot lat="0" lon="0" rev="0"/>
-            </a:camera>
-            <a:lightRig rig="threePt" dir="t">
-              <a:rot lat="0" lon="0" rev="1200000"/>
-            </a:lightRig>
-          </a:scene3d>
-          <a:sp3d>
-            <a:bevelT w="63500" h="25400"/>
-          </a:sp3d>
         </a:effectStyle>
       </a:effectStyleLst>
       <a:bgFillStyleLst>
         <a:solidFill>
           <a:schemeClr val="phClr"/>
         </a:solidFill>
+        <a:solidFill>
+          <a:schemeClr val="phClr">
+            <a:tint val="95000"/>
+            <a:satMod val="170000"/>
+          </a:schemeClr>
+        </a:solidFill>
         <a:gradFill rotWithShape="1">
           <a:gsLst>
             <a:gs pos="0">
               <a:schemeClr val="phClr">
-                <a:tint val="40000"/>
-                <a:satMod val="350000"/>
+                <a:tint val="93000"/>
+                <a:satMod val="150000"/>
+                <a:shade val="98000"/>
+                <a:lumMod val="102000"/>
               </a:schemeClr>
             </a:gs>
-            <a:gs pos="40000">
+            <a:gs pos="50000">
               <a:schemeClr val="phClr">
-                <a:tint val="45000"/>
-                <a:shade val="99000"/>
-                <a:satMod val="350000"/>
+                <a:tint val="98000"/>
+                <a:satMod val="130000"/>
+                <a:shade val="90000"/>
+                <a:lumMod val="103000"/>
               </a:schemeClr>
             </a:gs>
             <a:gs pos="100000">
               <a:schemeClr val="phClr">
-                <a:shade val="20000"/>
-                <a:satMod val="255000"/>
+                <a:shade val="63000"/>
+                <a:satMod val="120000"/>
               </a:schemeClr>
             </a:gs>
           </a:gsLst>
-          <a:path path="circle">
-            <a:fillToRect l="50000" t="-80000" r="50000" b="180000"/>
-          </a:path>
-        </a:gradFill>
-        <a:gradFill rotWithShape="1">
-          <a:gsLst>
-            <a:gs pos="0">
-              <a:schemeClr val="phClr">
-                <a:tint val="80000"/>
-                <a:satMod val="300000"/>
-              </a:schemeClr>
-            </a:gs>
-            <a:gs pos="100000">
-              <a:schemeClr val="phClr">
-                <a:shade val="30000"/>
-                <a:satMod val="200000"/>
-              </a:schemeClr>
-            </a:gs>
-          </a:gsLst>
-          <a:path path="circle">
-            <a:fillToRect l="50000" t="50000" r="50000" b="50000"/>
-          </a:path>
+          <a:lin ang="5400000" scaled="0"/>
         </a:gradFill>
       </a:bgFillStyleLst>
     </a:fmtScheme>
   </a:themeElements>
-  <a:objectDefaults>
-    <a:spDef>
-      <a:spPr/>
-      <a:bodyPr/>
-      <a:lstStyle/>
-      <a:style>
-        <a:lnRef idx="1">
-          <a:schemeClr val="accent1"/>
-        </a:lnRef>
-        <a:fillRef idx="3">
-          <a:schemeClr val="accent1"/>
-        </a:fillRef>
-        <a:effectRef idx="2">
-          <a:schemeClr val="accent1"/>
-        </a:effectRef>
-        <a:fontRef idx="minor">
-          <a:schemeClr val="lt1"/>
-        </a:fontRef>
-      </a:style>
-    </a:spDef>
-    <a:lnDef>
-      <a:spPr/>
-      <a:bodyPr/>
-      <a:lstStyle/>
-      <a:style>
-        <a:lnRef idx="2">
-          <a:schemeClr val="accent1"/>
-        </a:lnRef>
-        <a:fillRef idx="0">
-          <a:schemeClr val="accent1"/>
-        </a:fillRef>
-        <a:effectRef idx="1">
-          <a:schemeClr val="accent1"/>
-        </a:effectRef>
-        <a:fontRef idx="minor">
-          <a:schemeClr val="tx1"/>
-        </a:fontRef>
-      </a:style>
-    </a:lnDef>
-  </a:objectDefaults>
+  <a:objectDefaults/>
   <a:extraClrSchemeLst/>
+  <a:extLst>
+    <a:ext uri="{05A4C25C-085E-4340-85A3-A5531E510DB2}">
+      <thm15:themeFamily xmlns:thm15="http://schemas.microsoft.com/office/thememl/2012/main" name="Office Theme" id="{62F939B6-93AF-4DB8-9C6B-D6C7DFDC589F}" vid="{4A3C46E8-61CC-4603-A589-7422A47A8E4A}"/>
+    </a:ext>
+  </a:extLst>
 </a:theme>
 </file>
</xml_diff>